<commit_message>
Fix merged PPT: 12 slides complete
</commit_message>
<xml_diff>
--- a/DeepSeek-V4-Report-Full.pptx
+++ b/DeepSeek-V4-Report-Full.pptx
@@ -1,19 +1,121 @@
 
-<file path=ppt/presentation.xml><?xml version="1.0" encoding="UTF-8" standalone="yes"?>
-<p:presentation xmlns:a="http://schemas.openxmlformats.org/drawingml/2006/main" xmlns:r="http://schemas.openxmlformats.org/officeDocument/2006/relationships" xmlns:p="http://schemas.openxmlformats.org/presentationml/2006/main"  saveSubsetFonts="1" autoCompressPictures="0"><p:sldMasterIdLst><p:sldMasterId id="2147483648" r:id="rId1"/></p:sldMasterIdLst><p:sldIdLst><p:notesMasterIdLst><p:notesMasterId r:id="rId5"/></p:notesMasterIdLst><p:sldSz cx="9144000" cy="5143500"/><p:notesSz cx="5143500" cy="9144000"/><p:defaultTextStyle><a:lvl1pPr marL="0" algn="l" defTabSz="914400" rtl="0" eaLnBrk="1" latinLnBrk="0" hangingPunct="1"><a:defRPr sz="1800" kern="1200"><a:solidFill><a:schemeClr val="tx1"/></a:solidFill><a:latin typeface="+mn-lt"/><a:ea typeface="+mn-ea"/><a:cs typeface="+mn-cs"/></a:defRPr></a:lvl1pPr><a:lvl2pPr marL="457200" algn="l" defTabSz="914400" rtl="0" eaLnBrk="1" latinLnBrk="0" hangingPunct="1"><a:defRPr sz="1800" kern="1200"><a:solidFill><a:schemeClr val="tx1"/></a:solidFill><a:latin typeface="+mn-lt"/><a:ea typeface="+mn-ea"/><a:cs typeface="+mn-cs"/></a:defRPr></a:lvl2pPr><a:lvl3pPr marL="914400" algn="l" defTabSz="914400" rtl="0" eaLnBrk="1" latinLnBrk="0" hangingPunct="1"><a:defRPr sz="1800" kern="1200"><a:solidFill><a:schemeClr val="tx1"/></a:solidFill><a:latin typeface="+mn-lt"/><a:ea typeface="+mn-ea"/><a:cs typeface="+mn-cs"/></a:defRPr></a:lvl3pPr><a:lvl4pPr marL="1371600" algn="l" defTabSz="914400" rtl="0" eaLnBrk="1" latinLnBrk="0" hangingPunct="1"><a:defRPr sz="1800" kern="1200"><a:solidFill><a:schemeClr val="tx1"/></a:solidFill><a:latin typeface="+mn-lt"/><a:ea typeface="+mn-ea"/><a:cs typeface="+mn-cs"/></a:defRPr></a:lvl4pPr><a:lvl5pPr marL="1828800" algn="l" defTabSz="914400" rtl="0" eaLnBrk="1" latinLnBrk="0" hangingPunct="1"><a:defRPr sz="1800" kern="1200"><a:solidFill><a:schemeClr val="tx1"/></a:solidFill><a:latin typeface="+mn-lt"/><a:ea typeface="+mn-ea"/><a:cs typeface="+mn-cs"/></a:defRPr></a:lvl5pPr><a:lvl6pPr marL="2286000" algn="l" defTabSz="914400" rtl="0" eaLnBrk="1" latinLnBrk="0" hangingPunct="1"><a:defRPr sz="1800" kern="1200"><a:solidFill><a:schemeClr val="tx1"/></a:solidFill><a:latin typeface="+mn-lt"/><a:ea typeface="+mn-ea"/><a:cs typeface="+mn-cs"/></a:defRPr></a:lvl6pPr><a:lvl7pPr marL="2743200" algn="l" defTabSz="914400" rtl="0" eaLnBrk="1" latinLnBrk="0" hangingPunct="1"><a:defRPr sz="1800" kern="1200"><a:solidFill><a:schemeClr val="tx1"/></a:solidFill><a:latin typeface="+mn-lt"/><a:ea typeface="+mn-ea"/><a:cs typeface="+mn-cs"/></a:defRPr></a:lvl7pPr><a:lvl8pPr marL="3200400" algn="l" defTabSz="914400" rtl="0" eaLnBrk="1" latinLnBrk="0" hangingPunct="1"><a:defRPr sz="1800" kern="1200"><a:solidFill><a:schemeClr val="tx1"/></a:solidFill><a:latin typeface="+mn-lt"/><a:ea typeface="+mn-ea"/><a:cs typeface="+mn-cs"/></a:defRPr></a:lvl8pPr><a:lvl9pPr marL="3657600" algn="l" defTabSz="914400" rtl="0" eaLnBrk="1" latinLnBrk="0" hangingPunct="1"><a:defRPr sz="1800" kern="1200"><a:solidFill><a:schemeClr val="tx1"/></a:solidFill><a:latin typeface="+mn-lt"/><a:ea typeface="+mn-ea"/><a:cs typeface="+mn-cs"/></a:defRPr></a:lvl9pPr></p:defaultTextStyle></p:presentation>
-      <p:sldId id="257" r:id="rId5"/>
-      <p:sldId id="258" r:id="rId6"/>
-      <p:sldId id="259" r:id="rId7"/>
-      <p:sldId id="260" r:id="rId8"/>
-      <p:sldId id="261" r:id="rId9"/>
-      <p:sldId id="262" r:id="rId10"/>
-      <p:sldId id="263" r:id="rId11"/>
-      <p:sldId id="264" r:id="rId12"/>
-      <p:sldId id="265" r:id="rId13"/>
-      <p:sldId id="266" r:id="rId14"/>
-      <p:sldId id="267" r:id="rId15"/>
-      <p:sldId id="268" r:id="rId16"/>
-    </p:sldIdLst>
+<file path=ppt/presentation.xml><?xml version="1.0" encoding="utf-8"?>
+<p:presentation xmlns:a="http://schemas.openxmlformats.org/drawingml/2006/main" xmlns:r="http://schemas.openxmlformats.org/officeDocument/2006/relationships" xmlns:p="http://schemas.openxmlformats.org/presentationml/2006/main" saveSubsetFonts="1" autoCompressPictures="0">
+  <p:sldMasterIdLst>
+    <p:sldMasterId id="2147483648" r:id="rId1"/>
+  </p:sldMasterIdLst>
+  <p:sldIdLst>
+    <p:sldId id="257" r:id="rId5"/>
+    <p:sldId id="258" r:id="rId6"/>
+    <p:sldId id="259" r:id="rId7"/>
+    <p:sldId id="260" r:id="rId8"/>
+    <p:sldId id="261" r:id="rId9"/>
+    <p:sldId id="262" r:id="rId10"/>
+    <p:sldId id="263" r:id="rId11"/>
+    <p:sldId id="264" r:id="rId12"/>
+    <p:sldId id="265" r:id="rId13"/>
+    <p:sldId id="266" r:id="rId14"/>
+    <p:sldId id="267" r:id="rId15"/>
+    <p:sldId id="268" r:id="rId16"/>
+  </p:sldIdLst>
+  <p:notesMasterIdLst>
+    <p:notesMasterId r:id="rId5"/>
+  </p:notesMasterIdLst>
+  <p:sldSz cx="9144000" cy="5143500"/>
+  <p:notesSz cx="5143500" cy="9144000"/>
+  <p:defaultTextStyle>
+    <a:lvl1pPr marL="0" algn="l" defTabSz="914400" rtl="0" eaLnBrk="1" latinLnBrk="0" hangingPunct="1">
+      <a:defRPr sz="1800" kern="1200">
+        <a:solidFill>
+          <a:schemeClr val="tx1"/>
+        </a:solidFill>
+        <a:latin typeface="+mn-lt"/>
+        <a:ea typeface="+mn-ea"/>
+        <a:cs typeface="+mn-cs"/>
+      </a:defRPr>
+    </a:lvl1pPr>
+    <a:lvl2pPr marL="457200" algn="l" defTabSz="914400" rtl="0" eaLnBrk="1" latinLnBrk="0" hangingPunct="1">
+      <a:defRPr sz="1800" kern="1200">
+        <a:solidFill>
+          <a:schemeClr val="tx1"/>
+        </a:solidFill>
+        <a:latin typeface="+mn-lt"/>
+        <a:ea typeface="+mn-ea"/>
+        <a:cs typeface="+mn-cs"/>
+      </a:defRPr>
+    </a:lvl2pPr>
+    <a:lvl3pPr marL="914400" algn="l" defTabSz="914400" rtl="0" eaLnBrk="1" latinLnBrk="0" hangingPunct="1">
+      <a:defRPr sz="1800" kern="1200">
+        <a:solidFill>
+          <a:schemeClr val="tx1"/>
+        </a:solidFill>
+        <a:latin typeface="+mn-lt"/>
+        <a:ea typeface="+mn-ea"/>
+        <a:cs typeface="+mn-cs"/>
+      </a:defRPr>
+    </a:lvl3pPr>
+    <a:lvl4pPr marL="1371600" algn="l" defTabSz="914400" rtl="0" eaLnBrk="1" latinLnBrk="0" hangingPunct="1">
+      <a:defRPr sz="1800" kern="1200">
+        <a:solidFill>
+          <a:schemeClr val="tx1"/>
+        </a:solidFill>
+        <a:latin typeface="+mn-lt"/>
+        <a:ea typeface="+mn-ea"/>
+        <a:cs typeface="+mn-cs"/>
+      </a:defRPr>
+    </a:lvl4pPr>
+    <a:lvl5pPr marL="1828800" algn="l" defTabSz="914400" rtl="0" eaLnBrk="1" latinLnBrk="0" hangingPunct="1">
+      <a:defRPr sz="1800" kern="1200">
+        <a:solidFill>
+          <a:schemeClr val="tx1"/>
+        </a:solidFill>
+        <a:latin typeface="+mn-lt"/>
+        <a:ea typeface="+mn-ea"/>
+        <a:cs typeface="+mn-cs"/>
+      </a:defRPr>
+    </a:lvl5pPr>
+    <a:lvl6pPr marL="2286000" algn="l" defTabSz="914400" rtl="0" eaLnBrk="1" latinLnBrk="0" hangingPunct="1">
+      <a:defRPr sz="1800" kern="1200">
+        <a:solidFill>
+          <a:schemeClr val="tx1"/>
+        </a:solidFill>
+        <a:latin typeface="+mn-lt"/>
+        <a:ea typeface="+mn-ea"/>
+        <a:cs typeface="+mn-cs"/>
+      </a:defRPr>
+    </a:lvl6pPr>
+    <a:lvl7pPr marL="2743200" algn="l" defTabSz="914400" rtl="0" eaLnBrk="1" latinLnBrk="0" hangingPunct="1">
+      <a:defRPr sz="1800" kern="1200">
+        <a:solidFill>
+          <a:schemeClr val="tx1"/>
+        </a:solidFill>
+        <a:latin typeface="+mn-lt"/>
+        <a:ea typeface="+mn-ea"/>
+        <a:cs typeface="+mn-cs"/>
+      </a:defRPr>
+    </a:lvl7pPr>
+    <a:lvl8pPr marL="3200400" algn="l" defTabSz="914400" rtl="0" eaLnBrk="1" latinLnBrk="0" hangingPunct="1">
+      <a:defRPr sz="1800" kern="1200">
+        <a:solidFill>
+          <a:schemeClr val="tx1"/>
+        </a:solidFill>
+        <a:latin typeface="+mn-lt"/>
+        <a:ea typeface="+mn-ea"/>
+        <a:cs typeface="+mn-cs"/>
+      </a:defRPr>
+    </a:lvl8pPr>
+    <a:lvl9pPr marL="3657600" algn="l" defTabSz="914400" rtl="0" eaLnBrk="1" latinLnBrk="0" hangingPunct="1">
+      <a:defRPr sz="1800" kern="1200">
+        <a:solidFill>
+          <a:schemeClr val="tx1"/>
+        </a:solidFill>
+        <a:latin typeface="+mn-lt"/>
+        <a:ea typeface="+mn-ea"/>
+        <a:cs typeface="+mn-cs"/>
+      </a:defRPr>
+    </a:lvl9pPr>
+  </p:defaultTextStyle>
+</p:presentation>
 </file>
 
 <file path=ppt/notesMasters/notesMaster1.xml><?xml version="1.0" encoding="utf-8"?>

</xml_diff>